<commit_message>
Fix low-contrast icons on the applications slide
</commit_message>
<xml_diff>
--- a/slides/Autopsy_Demo_Team1.pptx
+++ b/slides/Autopsy_Demo_Team1.pptx
@@ -122,7 +122,7 @@
   <p:extLst>
     <p:ext uri="{521415D9-36F7-43E2-AB2F-B90AF26B5E84}">
       <p14:sectionLst xmlns:p14="http://schemas.microsoft.com/office/powerpoint/2010/main">
-        <p14:section name="Introduction" id="{0ac7d876-b4b1-34c2-8ae1-563c51f40c8f}">
+        <p14:section name="Introduction" id="{269290d0-1b55-b6ca-d76c-03afa6fc149f}">
           <p14:sldIdLst>
             <p14:sldId id="256"/>
             <p14:sldId id="257"/>
@@ -131,14 +131,14 @@
             <p14:sldId id="260"/>
           </p14:sldIdLst>
         </p14:section>
-        <p14:section name="Use case" id="{15461164-5035-6af9-7b39-5d8e6ff89e2c}">
+        <p14:section name="Use case" id="{9867eb20-0b6a-05c1-27c1-3925df4e7f0f}">
           <p14:sldIdLst>
             <p14:sldId id="261"/>
             <p14:sldId id="262"/>
             <p14:sldId id="263"/>
           </p14:sldIdLst>
         </p14:section>
-        <p14:section name="Findings" id="{aa932220-a9fc-aee8-71b5-b73b2f31f7a2}">
+        <p14:section name="Findings" id="{f5f4054b-ee6d-c894-67c9-dcf52dd008a3}">
           <p14:sldIdLst>
             <p14:sldId id="264"/>
             <p14:sldId id="265"/>
@@ -149,7 +149,7 @@
             <p14:sldId id="270"/>
           </p14:sldIdLst>
         </p14:section>
-        <p14:section name="Conclusion" id="{d2969f82-68fa-51a7-107c-a7e69b976087}">
+        <p14:section name="Conclusion" id="{ecb92fe0-0900-004f-f33d-a9c673f97c58}">
           <p14:sldIdLst>
             <p14:sldId id="271"/>
           </p14:sldIdLst>

</xml_diff>